<commit_message>
fix: draw the deck's links in ink and match its plan count and seed to the tests
</commit_message>
<xml_diff>
--- a/deck/cpomdp_symposium_2026.pptx
+++ b/deck/cpomdp_symposium_2026.pptx
@@ -1700,7 +1700,7 @@
           <a:lstStyle/>
           <a:p>
             <a:r>
-              <a:t>Kev. Pointers only. Two moves ahead costs 162 plans a step against 9.</a:t>
+              <a:t>Kev. Pointers only. Two moves ahead scores 81 plans a step against 9.</a:t>
             </a:r>
           </a:p>
         </p:txBody>
@@ -9657,7 +9657,7 @@
                 </a:solidFill>
                 <a:latin typeface="Calibri"/>
               </a:rPr>
-              <a:t>Put the same rock in clear sky on their arc and both curious rockets hit it on step 5.</a:t>
+              <a:t>Seed 3: put the same rock in clear sky on their arc and both curious rockets hit it on step 5.</a:t>
             </a:r>
           </a:p>
         </p:txBody>
@@ -12047,7 +12047,7 @@
                 </a:solidFill>
                 <a:latin typeface="Calibri"/>
               </a:rPr>
-              <a:t>The world again, two moves ahead. Each step scores 162 plans in place of 9.</a:t>
+              <a:t>The world again, two moves ahead. Each step scores 81 plans in place of 9.</a:t>
             </a:r>
           </a:p>
         </p:txBody>
@@ -16714,10 +16714,10 @@
         <a:srgbClr val="F79646"/>
       </a:accent6>
       <a:hlink>
-        <a:srgbClr val="0000FF"/>
+        <a:srgbClr val="F3F0E6"/>
       </a:hlink>
       <a:folHlink>
-        <a:srgbClr val="800080"/>
+        <a:srgbClr val="F3F0E6"/>
       </a:folHlink>
     </a:clrScheme>
     <a:fontScheme name="Office">

</xml_diff>

<commit_message>
chore: version 0.2.0 and rebuild the notebook and the deck on it
</commit_message>
<xml_diff>
--- a/deck/cpomdp_symposium_2026.pptx
+++ b/deck/cpomdp_symposium_2026.pptx
@@ -2677,7 +2677,7 @@
           <a:p/>
           <a:p>
             <a:r>
-              <a:t>Everything shown runs on cpomdp 0.5.0 from PyPI.</a:t>
+              <a:t>Everything shown runs on cpomdp 0.5.1 from PyPI.</a:t>
             </a:r>
           </a:p>
           <a:p/>
@@ -2929,7 +2929,7 @@
           <a:p/>
           <a:p>
             <a:r>
-              <a:t>Either way, cell 1 stops if cpomdp isn't 0.5.0 or Python is older than 3.11, and it prints what it found.</a:t>
+              <a:t>Either way, cell 1 stops if cpomdp isn't 0.5.1 or Python is older than 3.11, and it prints what it found.</a:t>
             </a:r>
           </a:p>
         </p:txBody>
@@ -6548,7 +6548,7 @@
                 </a:solidFill>
                 <a:latin typeface="Courier New"/>
               </a:rPr>
-              <a:t>cpomdp 0.5.0</a:t>
+              <a:t>cpomdp 0.5.1</a:t>
             </a:r>
           </a:p>
         </p:txBody>
@@ -17886,7 +17886,7 @@
                 </a:solidFill>
                 <a:latin typeface="Calibri"/>
               </a:rPr>
-              <a:t>today's notebook pins 0.5.0. Some of its src was written by Claude Code under the review described.</a:t>
+              <a:t>today's notebook pins 0.5.1. Some of its src was written by Claude Code under the review described.</a:t>
             </a:r>
           </a:p>
         </p:txBody>
@@ -18526,7 +18526,7 @@
                 </a:solidFill>
                 <a:latin typeface="Calibri"/>
               </a:rPr>
-              <a:t>[Zenodo DOI of cpomdp 0.5.0]</a:t>
+              <a:t>[Zenodo DOI of cpomdp 0.5.1]</a:t>
             </a:r>
           </a:p>
         </p:txBody>
@@ -18957,7 +18957,7 @@
                 </a:solidFill>
                 <a:latin typeface="Calibri"/>
               </a:rPr>
-              <a:t>Everything shown runs on cpomdp 0.5.0 from PyPI.</a:t>
+              <a:t>Everything shown runs on cpomdp 0.5.1 from PyPI.</a:t>
             </a:r>
           </a:p>
         </p:txBody>
@@ -21363,7 +21363,7 @@
                 </a:solidFill>
                 <a:latin typeface="Courier New"/>
               </a:rPr>
-              <a:t>pip install cpomdp-workshop==0.1.0</a:t>
+              <a:t>pip install cpomdp-workshop==0.2.0</a:t>
             </a:r>
           </a:p>
         </p:txBody>

</xml_diff>

<commit_message>
docs: refine workshop instructions and Task 1 discussion
</commit_message>
<xml_diff>
--- a/deck/cpomdp_symposium_2026.pptx
+++ b/deck/cpomdp_symposium_2026.pptx
@@ -690,19 +690,43 @@
           <a:lstStyle/>
           <a:p>
             <a:r>
-              <a:t>Planned at 0:31. Keyboard shows what the cell printed. The rocket is LQR, and lands 0.13 from the pad.</a:t>
+              <a:t>Planned at 0:31. Kev invites participants to compare their results with the reference route and spread. The rocket is LQR, and lands 0.13 from the pad.</a:t>
             </a:r>
           </a:p>
           <a:p/>
           <a:p>
             <a:r>
-              <a:t>The probe compares the information each of the nine compass moves is expected to give. spread = 0.000000 nats, so no move gives more than any other. Every spread in the chat should read zero, whatever the bonuses changed.</a:t>
+              <a:t>Ask what a spread of zero tells us. Then ask those who tried the bonus exercises what changed and what stayed the same. Give participants time to discuss before explaining the result.</a:t>
             </a:r>
           </a:p>
           <a:p/>
           <a:p>
             <a:r>
-              <a:t>Then poll 1 for 60 s. Kev reads the split.</a:t>
+              <a:t>The probe compares the information each of the nine compass moves is expected to give. spread = 0.000000 nats, so no move gives more than any other. Zero spread does not mean zero information gain. The bonus changes can alter the amount of information gained, while the spread remains zero.</a:t>
+            </a:r>
+          </a:p>
+          <a:p/>
+          <a:p>
+            <a:r>
+              <a:t>Then poll 1 for 60 seconds. Kev reads the split. Use the following slide to introduce how position-dependent sensor noise can make expected information gain differ between moves.</a:t>
+            </a:r>
+          </a:p>
+          <a:p/>
+          <a:p>
+            <a:r>
+              <a:t>After the poll, connect the result to what we call the Koudahl collapse. Koudahl, Kouw and de Vries (2021) show that, for the linear Gaussian models and full expected free energy (EFE) objective they analyse, EFE reduces to the KL-control objective plus a constant determined by observation noise. Minimising EFE therefore supplies no purposeful exploratory (epistemic) drive in that setting.</a:t>
+            </a:r>
+          </a:p>
+          <a:p/>
+          <a:p>
+            <a:r>
+              <a:t>Here, with fixed sensor noise and additive controls, every candidate move has the same expected information gain. The epistemic contribution cannot favour one move over another, which is why spread is zero. Zero spread does not mean zero information gain.</a:t>
+            </a:r>
+          </a:p>
+          <a:p/>
+          <a:p>
+            <a:r>
+              <a:t>Reference: Koudahl, M. T., Kouw, W. M. and de Vries, B. (2021). On Epistemics in Expected Free Energy for Linear Gaussian State Space Models. Entropy. https://doi.org/10.3390/e23121565</a:t>
             </a:r>
           </a:p>
           <a:p/>
@@ -817,25 +841,67 @@
           <a:lstStyle/>
           <a:p>
             <a:r>
-              <a:t>Kev. If you've built a continuous active inference agent and watched it behave like a controller, you didn't do anything wrong.</a:t>
+              <a:t>R describes the noise in the sensor readings. Writing R(x) means that this noise depends on the rocket’s position.</a:t>
             </a:r>
           </a:p>
           <a:p/>
           <a:p>
             <a:r>
-              <a:t>The Kalman filter's uncertainty after a reading depends on the noise and the uncertainty before it, never on the move or the position. With the same noise everywhere, every move leaves the rocket equally uncertain, so the information term is the same for all of them. What's left of expected free energy is LQR. Koudahl, Kouw and de Vries published that result in 2021.</a:t>
+              <a:t>Near the beacon, readings are clearer. By moving towards it, the rocket can obtain a more informative measurement and reduce its uncertainty about where it is. Movement can therefore affect both progress towards the goal and what the rocket learns.</a:t>
             </a:r>
           </a:p>
           <a:p/>
           <a:p>
             <a:r>
-              <a:t>Bonus 2 asked whether unequal noise across the axes would change that. It changes how much each reading tells the rocket, but not the spread between moves, because the noise is still fixed in place. That's the bridge to Task 2.</a:t>
+              <a:t>This expected reduction in uncertainty is called epistemic value. With our sensor model, some moves can offer more information than others.</a:t>
             </a:r>
           </a:p>
           <a:p/>
           <a:p>
             <a:r>
-              <a:t>The rest of the session changes one thing. The noise depends on where the rocket is.</a:t>
+              <a:t>State-dependent sensory precision has a history in active inference. Dan’s contribution establishes conditions under which it makes epistemic value depend on action and rules out an equivalent fixed linear-Gaussian filter.</a:t>
+            </a:r>
+          </a:p>
+          <a:p/>
+          <a:p>
+            <a:r>
+              <a:t>The mean dynamics and observation map remain linear, and the conditional noise distributions remain Gaussian. However, the joint model is no longer fully Gaussian.</a:t>
+            </a:r>
+          </a:p>
+          <a:p/>
+          <a:p>
+            <a:r>
+              <a:t>Tasks 2 and 3 explore this mechanism. Whether it changes the chosen route also depends on the objective and planning horizon.</a:t>
+            </a:r>
+          </a:p>
+          <a:p/>
+          <a:p>
+            <a:r>
+              <a:t>R(x) is one route to action-dependent information gain. Another modelling choice is multiplicative control, where an action selects the dynamics governing how the state evolves. Koudahl, Kouw and de Vries show that this can produce exploration when the epistemic term is optimised on its own. Their full EFE objective still reduces to KL control plus a constant, so these results concern different objective choices.</a:t>
+            </a:r>
+          </a:p>
+          <a:p/>
+          <a:p>
+            <a:r>
+              <a:t>A biological illustration of actions changing dynamics is muscle co-contraction. Activating opposing muscles together can increase joint stiffness with little change in net torque. The limb then responds differently to the same disturbance. In a simplified model, muscle activation changes the stiffness multiplying the displacement, which can be represented using multiplicative control. This illustrates a change in dynamics; it does not by itself demonstrate information-seeking behaviour. We use R(x) in the workshop because the beacon and blackout change the reliability of observations across locations.</a:t>
+            </a:r>
+          </a:p>
+          <a:p/>
+          <a:p>
+            <a:r>
+              <a:t>Reference: Corva, D. (2026). State-Dependent Observation Noise Reintroduces Epistemic Value in Linear-Gaussian Active Inference. Sections 2.3 and 3, Theorem 1. https://arxiv.org/abs/2607.20306</a:t>
+            </a:r>
+          </a:p>
+          <a:p/>
+          <a:p>
+            <a:r>
+              <a:t>Further references: Koudahl, M. T., Kouw, W. M. and de Vries, B. (2021). On Epistemics in Expected Free Energy for Linear Gaussian State Space Models. https://doi.org/10.3390/e23121565</a:t>
+            </a:r>
+          </a:p>
+          <a:p/>
+          <a:p>
+            <a:r>
+              <a:t>Franklin, D. W. et al. (2007). Endpoint Stiffness of the Arm Is Directionally Tuned to Instability in the Environment. https://pmc.ncbi.nlm.nih.gov/articles/PMC6672883/</a:t>
             </a:r>
           </a:p>
         </p:txBody>
@@ -2835,13 +2901,13 @@
           <a:lstStyle/>
           <a:p>
             <a:r>
-              <a:t>Keyboard. Each task has two lines to write, and we've written the rest of the code, so the Python stays out of the way. Some of the bonus exercises ask you to write your own.</a:t>
+              <a:t>Keyboard. Each task has two lines to write, and we have written the rest of the code, so the Python stays out of the way. Some of the bonus exercises ask you to write your own.</a:t>
             </a:r>
           </a:p>
           <a:p/>
           <a:p>
             <a:r>
-              <a:t>Each task has two hints and a reference solution, collapsed below the cell. A hint shows its nudge first, and the line itself is behind Show code. Open them whenever you like, and using them isn't failing.</a:t>
+              <a:t>Each task has two hints and a reference solution, collapsed below the cell. A hint shows its nudge first, and the line itself is behind Show code. Open them whenever you like, and using them is not failing.</a:t>
             </a:r>
           </a:p>
           <a:p/>
@@ -2853,7 +2919,7 @@
           <a:p/>
           <a:p>
             <a:r>
-              <a:t>Each task closes with one number in the chat. It lets us see how the room is doing without anyone writing a sentence. Then there's a one-minute poll.</a:t>
+              <a:t>Each task closes with one number in the chat. It lets us see how the room is doing without anyone writing a sentence. Then there is a one-minute poll.</a:t>
             </a:r>
           </a:p>
         </p:txBody>
@@ -3005,7 +3071,7 @@
           <a:lstStyle/>
           <a:p>
             <a:r>
-              <a:t>Kev. Before we build anything, here's where we're heading. Run cell 2 and you'll see this picture.</a:t>
+              <a:t>Kev. Introduce the preview before beginning the tasks. Run the second code cell, then ask: What makes these rockets take different routes?</a:t>
             </a:r>
           </a:p>
           <a:p/>
@@ -3017,7 +3083,7 @@
           <a:p/>
           <a:p>
             <a:r>
-              <a:t>Don't worry if you can't explain it yet. Neither rocket knows the rock is there, and working out what's going on is what the three tasks are for.</a:t>
+              <a:t>Do not worry if you cannot explain it yet. Neither rocket knows the rock is there, and working out what is going on is what the three tasks are for.</a:t>
             </a:r>
           </a:p>
         </p:txBody>
@@ -3093,19 +3159,19 @@
           <a:p/>
           <a:p>
             <a:r>
-              <a:t>Our first rocket is the classic one. A Kalman filter estimates its position from noisy readings, and a linear quadratic regulator steers it to the pad. Its sensor is equally reliable everywhere. So does every move give the rocket the same amount of information? Hold that question.</a:t>
+              <a:t>Our first rocket is the classic one. A Kalman filter estimates its position from noisy readings, and a linear quadratic regulator steers it to the pad. Its sensor has the same level of noise everywhere. Are all possible moves equally informative? Hold that question.</a:t>
             </a:r>
           </a:p>
           <a:p/>
           <a:p>
             <a:r>
-              <a:t>If you know pymdp, the cards map its letters onto cpomdp's fields. A is the observation likelihood. In cpomdp that's the observation_matrix together with the observation_noise, R, because the noise is part of what a reading says about the state. B is the transition, so dynamics_matrix, with control_matrix for where a move enters. C is the preference, which we meet in Task 2 as Preference. D is the prior.</a:t>
+              <a:t>If you know pymdp, the cards map its letters onto cpomdp's fields. A is the observation likelihood. In cpomdp that is the observation_matrix together with the observation_noise, R, because the noise is part of what a reading says about the state. B is the transition, so dynamics_matrix, with control_matrix for where a move enters. C is the preference, which we meet in Task 2 as Preference. D is the prior.</a:t>
             </a:r>
           </a:p>
           <a:p/>
           <a:p>
             <a:r>
-              <a:t>The 1960 rocket's StateGoal has no pymdp letter. It's a goal over states with a thruster cost, which is what makes it an LQR controller.</a:t>
+              <a:t>The 1960 rocket's StateGoal has no pymdp letter. It is a goal over states with a thruster cost, which is what makes it an LQR controller.</a:t>
             </a:r>
           </a:p>
         </p:txBody>
@@ -7505,7 +7571,7 @@
                 </a:solidFill>
                 <a:latin typeface="Calibri"/>
               </a:rPr>
-              <a:t>The 1960 rocket flies the straight line</a:t>
+              <a:t>Task 1 · Discussion</a:t>
             </a:r>
           </a:p>
         </p:txBody>
@@ -7595,321 +7661,222 @@
       </p:pic>
       <p:sp>
         <p:nvSpPr>
-          <p:cNvPr id="5" name="printed"/>
-          <p:cNvSpPr/>
-          <p:nvPr/>
-        </p:nvSpPr>
-        <p:spPr>
-          <a:xfrm>
-            <a:off x="548640" y="5468112"/>
-            <a:ext cx="7680960" cy="886968"/>
-          </a:xfrm>
-          <a:prstGeom prst="roundRect">
-            <a:avLst>
-              <a:gd name="adj" fmla="val 8000"/>
-            </a:avLst>
-          </a:prstGeom>
-          <a:noFill/>
-          <a:ln w="12700">
-            <a:solidFill>
-              <a:srgbClr val="D3CEBF"/>
-            </a:solidFill>
-          </a:ln>
-          <a:effectLst/>
-        </p:spPr>
-        <p:style>
-          <a:lnRef idx="1">
-            <a:schemeClr val="accent1"/>
-          </a:lnRef>
-          <a:fillRef idx="3">
-            <a:schemeClr val="accent1"/>
-          </a:fillRef>
-          <a:effectRef idx="2">
-            <a:schemeClr val="accent1"/>
-          </a:effectRef>
-          <a:fontRef idx="minor">
-            <a:schemeClr val="lt1"/>
-          </a:fontRef>
-        </p:style>
-        <p:txBody>
-          <a:bodyPr rtlCol="0" anchor="ctr" wrap="square" lIns="164592" rIns="164592" tIns="115214" bIns="115214"/>
-          <a:lstStyle/>
-          <a:p>
-            <a:pPr algn="l">
-              <a:lnSpc>
-                <a:spcPct val="100000"/>
-              </a:lnSpc>
-              <a:spcAft>
-                <a:spcPts val="0"/>
-              </a:spcAft>
-            </a:pPr>
-            <a:r>
-              <a:rPr sz="1100" b="0">
-                <a:solidFill>
-                  <a:srgbClr val="16241F"/>
-                </a:solidFill>
-                <a:latin typeface="Courier New"/>
-              </a:rPr>
-              <a:t>Agent(objective=StateGoal, selector=LQRSelector(controller=LQRController(gain=[[0.0951, 0.0], [0.0, 0.0951]])), backend=KalmanBackend)</a:t>
-            </a:r>
-          </a:p>
-          <a:p>
-            <a:pPr algn="l">
-              <a:lnSpc>
-                <a:spcPct val="100000"/>
-              </a:lnSpc>
-              <a:spcAft>
-                <a:spcPts val="0"/>
-              </a:spcAft>
-            </a:pPr>
-            <a:r>
-              <a:rPr sz="1100" b="0">
-                <a:solidFill>
-                  <a:srgbClr val="16241F"/>
-                </a:solidFill>
-                <a:latin typeface="Courier New"/>
-              </a:rPr>
-              <a:t>after 36 moves it is at (4.87, 0.04), 0.13 from the pad</a:t>
-            </a:r>
-          </a:p>
-          <a:p>
-            <a:pPr algn="l">
-              <a:lnSpc>
-                <a:spcPct val="100000"/>
-              </a:lnSpc>
-            </a:pPr>
-            <a:r>
-              <a:rPr sz="1100" b="0">
-                <a:solidFill>
-                  <a:srgbClr val="16241F"/>
-                </a:solidFill>
-                <a:latin typeface="Courier New"/>
-              </a:rPr>
-              <a:t>epistemic_varies = False   flattens = True   spread = 0.000000 nats</a:t>
-            </a:r>
-          </a:p>
-        </p:txBody>
-      </p:sp>
-      <p:sp>
-        <p:nvSpPr>
-          <p:cNvPr id="6" name="card"/>
-          <p:cNvSpPr/>
+          <p:cNvPr id="9" name="text"/>
+          <p:cNvSpPr txBox="1"/>
           <p:nvPr/>
         </p:nvSpPr>
         <p:spPr>
           <a:xfrm>
             <a:off x="8503920" y="1325880"/>
-            <a:ext cx="3139135" cy="2697480"/>
+            <a:ext cx="3139135" cy="320040"/>
           </a:xfrm>
-          <a:prstGeom prst="roundRect">
-            <a:avLst>
-              <a:gd name="adj" fmla="val 4067"/>
-            </a:avLst>
+          <a:prstGeom prst="rect">
+            <a:avLst/>
           </a:prstGeom>
-          <a:solidFill>
-            <a:srgbClr val="FFFFFF"/>
-          </a:solidFill>
-          <a:ln>
-            <a:noFill/>
-          </a:ln>
-          <a:effectLst/>
+          <a:noFill/>
         </p:spPr>
-        <p:style>
-          <a:lnRef idx="1">
-            <a:schemeClr val="accent1"/>
-          </a:lnRef>
-          <a:fillRef idx="3">
-            <a:schemeClr val="accent1"/>
-          </a:fillRef>
-          <a:effectRef idx="2">
-            <a:schemeClr val="accent1"/>
-          </a:effectRef>
-          <a:fontRef idx="minor">
-            <a:schemeClr val="lt1"/>
-          </a:fontRef>
-        </p:style>
-        <p:txBody>
-          <a:bodyPr rtlCol="0" anchor="ctr" wrap="square" lIns="164592" rIns="164592" tIns="115214" bIns="115214"/>
-          <a:lstStyle/>
-          <a:p>
-            <a:pPr algn="l">
-              <a:lnSpc>
-                <a:spcPct val="100000"/>
-              </a:lnSpc>
-              <a:spcAft>
-                <a:spcPts val="600"/>
-              </a:spcAft>
-            </a:pPr>
-            <a:r>
-              <a:rPr sz="1700" b="0">
+        <p:txBody>
+          <a:bodyPr wrap="square" lIns="0" rIns="0" tIns="0" bIns="0" anchor="t">
+            <a:spAutoFit/>
+          </a:bodyPr>
+          <a:lstStyle/>
+          <a:p>
+            <a:pPr algn="l">
+              <a:lnSpc>
+                <a:spcPct val="100000"/>
+              </a:lnSpc>
+            </a:pPr>
+            <a:r>
+              <a:rPr sz="1500" b="0">
                 <a:solidFill>
                   <a:srgbClr val="5B6F68"/>
                 </a:solidFill>
                 <a:latin typeface="Calibri"/>
               </a:rPr>
-              <a:t>spread</a:t>
-            </a:r>
-          </a:p>
-          <a:p>
-            <a:pPr algn="l">
-              <a:lnSpc>
-                <a:spcPct val="100000"/>
-              </a:lnSpc>
-              <a:spcAft>
-                <a:spcPts val="600"/>
-              </a:spcAft>
-            </a:pPr>
-            <a:r>
-              <a:rPr sz="3600" b="1">
-                <a:solidFill>
-                  <a:srgbClr val="16241F"/>
-                </a:solidFill>
-                <a:latin typeface="Courier New"/>
-              </a:rPr>
-              <a:t>0.000000</a:t>
-            </a:r>
-          </a:p>
-          <a:p>
-            <a:pPr algn="l">
-              <a:lnSpc>
-                <a:spcPct val="100000"/>
-              </a:lnSpc>
-            </a:pPr>
-            <a:r>
-              <a:rPr sz="1700" b="0">
-                <a:solidFill>
-                  <a:srgbClr val="16241F"/>
-                </a:solidFill>
-                <a:latin typeface="Calibri"/>
-              </a:rPr>
-              <a:t>nats between the most and the least informative move</a:t>
-            </a:r>
-          </a:p>
-        </p:txBody>
-      </p:sp>
-      <p:sp>
-        <p:nvSpPr>
-          <p:cNvPr id="7" name="card"/>
-          <p:cNvSpPr/>
+              <a:t>Reference result</a:t>
+            </a:r>
+          </a:p>
+        </p:txBody>
+      </p:sp>
+      <p:sp>
+        <p:nvSpPr>
+          <p:cNvPr id="10" name="text"/>
+          <p:cNvSpPr txBox="1"/>
           <p:nvPr/>
         </p:nvSpPr>
         <p:spPr>
           <a:xfrm>
-            <a:off x="8503920" y="4251960"/>
-            <a:ext cx="3139135" cy="960120"/>
+            <a:off x="8503920" y="1719072"/>
+            <a:ext cx="3139135" cy="457200"/>
           </a:xfrm>
-          <a:prstGeom prst="roundRect">
-            <a:avLst>
-              <a:gd name="adj" fmla="val 8000"/>
-            </a:avLst>
+          <a:prstGeom prst="rect">
+            <a:avLst/>
           </a:prstGeom>
-          <a:solidFill>
-            <a:srgbClr val="FFFFFF"/>
-          </a:solidFill>
-          <a:ln w="12700">
-            <a:solidFill>
-              <a:srgbClr val="E69F00"/>
-            </a:solidFill>
-          </a:ln>
-          <a:effectLst/>
+          <a:noFill/>
         </p:spPr>
-        <p:style>
-          <a:lnRef idx="1">
-            <a:schemeClr val="accent1"/>
-          </a:lnRef>
-          <a:fillRef idx="3">
-            <a:schemeClr val="accent1"/>
-          </a:fillRef>
-          <a:effectRef idx="2">
-            <a:schemeClr val="accent1"/>
-          </a:effectRef>
-          <a:fontRef idx="minor">
-            <a:schemeClr val="lt1"/>
-          </a:fontRef>
-        </p:style>
-        <p:txBody>
-          <a:bodyPr rtlCol="0" anchor="ctr" wrap="square" lIns="164592" rIns="164592" tIns="115214" bIns="115214"/>
-          <a:lstStyle/>
-          <a:p>
-            <a:pPr algn="l">
-              <a:lnSpc>
-                <a:spcPct val="100000"/>
-              </a:lnSpc>
-              <a:spcAft>
-                <a:spcPts val="200"/>
-              </a:spcAft>
-            </a:pPr>
-            <a:r>
-              <a:rPr sz="1700" b="0">
-                <a:solidFill>
-                  <a:srgbClr val="5B6F68"/>
-                </a:solidFill>
-                <a:latin typeface="Calibri"/>
-              </a:rPr>
-              <a:t>Paste in chat</a:t>
-            </a:r>
-          </a:p>
-          <a:p>
-            <a:pPr algn="l">
-              <a:lnSpc>
-                <a:spcPct val="100000"/>
-              </a:lnSpc>
-            </a:pPr>
-            <a:r>
-              <a:rPr sz="1700" b="0">
+        <p:txBody>
+          <a:bodyPr wrap="square" lIns="0" rIns="0" tIns="0" bIns="0" anchor="t">
+            <a:spAutoFit/>
+          </a:bodyPr>
+          <a:lstStyle/>
+          <a:p>
+            <a:pPr algn="l">
+              <a:lnSpc>
+                <a:spcPct val="100000"/>
+              </a:lnSpc>
+            </a:pPr>
+            <a:r>
+              <a:rPr sz="1800" b="1">
                 <a:solidFill>
                   <a:srgbClr val="16241F"/>
                 </a:solidFill>
                 <a:latin typeface="Courier New"/>
               </a:rPr>
-              <a:t>spread</a:t>
-            </a:r>
-          </a:p>
-        </p:txBody>
-      </p:sp>
-      <p:sp>
-        <p:nvSpPr>
-          <p:cNvPr id="8" name="pill"/>
-          <p:cNvSpPr/>
+              <a:t>spread = 0.000000 nats</a:t>
+            </a:r>
+          </a:p>
+        </p:txBody>
+      </p:sp>
+      <p:sp>
+        <p:nvSpPr>
+          <p:cNvPr id="11" name="text"/>
+          <p:cNvSpPr txBox="1"/>
           <p:nvPr/>
         </p:nvSpPr>
         <p:spPr>
           <a:xfrm>
-            <a:off x="8503920" y="5468112"/>
-            <a:ext cx="3139135" cy="502920"/>
+            <a:off x="8503920" y="2286000"/>
+            <a:ext cx="3139135" cy="1051560"/>
           </a:xfrm>
-          <a:prstGeom prst="roundRect">
-            <a:avLst>
-              <a:gd name="adj" fmla="val 8000"/>
-            </a:avLst>
+          <a:prstGeom prst="rect">
+            <a:avLst/>
           </a:prstGeom>
           <a:noFill/>
-          <a:ln w="12700">
-            <a:solidFill>
-              <a:srgbClr val="D3CEBF"/>
-            </a:solidFill>
-          </a:ln>
-          <a:effectLst/>
         </p:spPr>
-        <p:style>
-          <a:lnRef idx="1">
-            <a:schemeClr val="accent1"/>
-          </a:lnRef>
-          <a:fillRef idx="3">
-            <a:schemeClr val="accent1"/>
-          </a:fillRef>
-          <a:effectRef idx="2">
-            <a:schemeClr val="accent1"/>
-          </a:effectRef>
-          <a:fontRef idx="minor">
-            <a:schemeClr val="lt1"/>
-          </a:fontRef>
-        </p:style>
-        <p:txBody>
-          <a:bodyPr rtlCol="0" anchor="ctr" wrap="square" lIns="73152" rIns="73152" tIns="18288" bIns="18288"/>
-          <a:lstStyle/>
-          <a:p>
-            <a:pPr algn="ctr">
+        <p:txBody>
+          <a:bodyPr wrap="square" lIns="0" rIns="0" tIns="0" bIns="0" anchor="t">
+            <a:spAutoFit/>
+          </a:bodyPr>
+          <a:lstStyle/>
+          <a:p>
+            <a:pPr algn="l">
+              <a:lnSpc>
+                <a:spcPct val="100000"/>
+              </a:lnSpc>
+            </a:pPr>
+            <a:r>
+              <a:rPr sz="1700" b="0">
+                <a:solidFill>
+                  <a:srgbClr val="5B6F68"/>
+                </a:solidFill>
+                <a:latin typeface="Calibri"/>
+              </a:rPr>
+              <a:t>The difference between the highest and lowest expected information gain across the possible moves.</a:t>
+            </a:r>
+          </a:p>
+        </p:txBody>
+      </p:sp>
+      <p:sp>
+        <p:nvSpPr>
+          <p:cNvPr id="12" name="text"/>
+          <p:cNvSpPr txBox="1"/>
+          <p:nvPr/>
+        </p:nvSpPr>
+        <p:spPr>
+          <a:xfrm>
+            <a:off x="8503920" y="3566160"/>
+            <a:ext cx="3139135" cy="685800"/>
+          </a:xfrm>
+          <a:prstGeom prst="rect">
+            <a:avLst/>
+          </a:prstGeom>
+          <a:noFill/>
+        </p:spPr>
+        <p:txBody>
+          <a:bodyPr wrap="square" lIns="0" rIns="0" tIns="0" bIns="0" anchor="t">
+            <a:spAutoFit/>
+          </a:bodyPr>
+          <a:lstStyle/>
+          <a:p>
+            <a:pPr algn="l">
+              <a:lnSpc>
+                <a:spcPct val="100000"/>
+              </a:lnSpc>
+            </a:pPr>
+            <a:r>
+              <a:rPr sz="2000" b="1">
+                <a:solidFill>
+                  <a:srgbClr val="16241F"/>
+                </a:solidFill>
+                <a:latin typeface="Calibri"/>
+              </a:rPr>
+              <a:t>What does a spread of zero tell us?</a:t>
+            </a:r>
+          </a:p>
+        </p:txBody>
+      </p:sp>
+      <p:sp>
+        <p:nvSpPr>
+          <p:cNvPr id="13" name="text"/>
+          <p:cNvSpPr txBox="1"/>
+          <p:nvPr/>
+        </p:nvSpPr>
+        <p:spPr>
+          <a:xfrm>
+            <a:off x="8503920" y="4434840"/>
+            <a:ext cx="3139135" cy="1280160"/>
+          </a:xfrm>
+          <a:prstGeom prst="rect">
+            <a:avLst/>
+          </a:prstGeom>
+          <a:noFill/>
+        </p:spPr>
+        <p:txBody>
+          <a:bodyPr wrap="square" lIns="0" rIns="0" tIns="0" bIns="0" anchor="t">
+            <a:spAutoFit/>
+          </a:bodyPr>
+          <a:lstStyle/>
+          <a:p>
+            <a:pPr algn="l">
+              <a:lnSpc>
+                <a:spcPct val="100000"/>
+              </a:lnSpc>
+            </a:pPr>
+            <a:r>
+              <a:rPr sz="1900" b="1">
+                <a:solidFill>
+                  <a:srgbClr val="16241F"/>
+                </a:solidFill>
+                <a:latin typeface="Calibri"/>
+              </a:rPr>
+              <a:t>If you tried the bonus exercises, what changed and what stayed the same?</a:t>
+            </a:r>
+          </a:p>
+        </p:txBody>
+      </p:sp>
+      <p:sp>
+        <p:nvSpPr>
+          <p:cNvPr id="14" name="text"/>
+          <p:cNvSpPr txBox="1"/>
+          <p:nvPr/>
+        </p:nvSpPr>
+        <p:spPr>
+          <a:xfrm>
+            <a:off x="8503920" y="6080760"/>
+            <a:ext cx="3139135" cy="320040"/>
+          </a:xfrm>
+          <a:prstGeom prst="rect">
+            <a:avLst/>
+          </a:prstGeom>
+          <a:noFill/>
+        </p:spPr>
+        <p:txBody>
+          <a:bodyPr wrap="square" lIns="0" rIns="0" tIns="0" bIns="0" anchor="t">
+            <a:spAutoFit/>
+          </a:bodyPr>
+          <a:lstStyle/>
+          <a:p>
+            <a:pPr algn="l">
               <a:lnSpc>
                 <a:spcPct val="100000"/>
               </a:lnSpc>
@@ -7921,7 +7888,7 @@
                 </a:solidFill>
                 <a:latin typeface="Calibri"/>
               </a:rPr>
-              <a:t>Poll 1 · 60 s</a:t>
+              <a:t>Poll 1 · 60 seconds</a:t>
             </a:r>
           </a:p>
         </p:txBody>
@@ -7986,7 +7953,7 @@
                 </a:solidFill>
                 <a:latin typeface="Calibri"/>
               </a:rPr>
-              <a:t>Under a fixed sensor, expected free energy is LQR</a:t>
+              <a:t>Making information gain depend on the action</a:t>
             </a:r>
           </a:p>
         </p:txBody>
@@ -8052,284 +8019,14 @@
       </p:sp>
       <p:sp>
         <p:nvSpPr>
-          <p:cNvPr id="4" name="card"/>
-          <p:cNvSpPr/>
+          <p:cNvPr id="4" name="text"/>
+          <p:cNvSpPr txBox="1"/>
           <p:nvPr/>
         </p:nvSpPr>
         <p:spPr>
           <a:xfrm>
             <a:off x="548640" y="1325880"/>
-            <a:ext cx="5364327" cy="3291840"/>
-          </a:xfrm>
-          <a:prstGeom prst="roundRect">
-            <a:avLst>
-              <a:gd name="adj" fmla="val 3333"/>
-            </a:avLst>
-          </a:prstGeom>
-          <a:solidFill>
-            <a:srgbClr val="FFFFFF"/>
-          </a:solidFill>
-          <a:ln>
-            <a:noFill/>
-          </a:ln>
-          <a:effectLst/>
-        </p:spPr>
-        <p:style>
-          <a:lnRef idx="1">
-            <a:schemeClr val="accent1"/>
-          </a:lnRef>
-          <a:fillRef idx="3">
-            <a:schemeClr val="accent1"/>
-          </a:fillRef>
-          <a:effectRef idx="2">
-            <a:schemeClr val="accent1"/>
-          </a:effectRef>
-          <a:fontRef idx="minor">
-            <a:schemeClr val="lt1"/>
-          </a:fontRef>
-        </p:style>
-        <p:txBody>
-          <a:bodyPr rtlCol="0" anchor="t" wrap="square" lIns="164592" rIns="164592" tIns="115214" bIns="115214"/>
-          <a:lstStyle/>
-          <a:p>
-            <a:pPr algn="l">
-              <a:lnSpc>
-                <a:spcPct val="100000"/>
-              </a:lnSpc>
-              <a:spcAft>
-                <a:spcPts val="1000"/>
-              </a:spcAft>
-            </a:pPr>
-            <a:r>
-              <a:rPr sz="4400" b="1">
-                <a:solidFill>
-                  <a:srgbClr val="16241F"/>
-                </a:solidFill>
-                <a:latin typeface="Courier New"/>
-              </a:rPr>
-              <a:t>R</a:t>
-            </a:r>
-          </a:p>
-          <a:p>
-            <a:pPr algn="l">
-              <a:lnSpc>
-                <a:spcPct val="100000"/>
-              </a:lnSpc>
-              <a:spcAft>
-                <a:spcPts val="1000"/>
-              </a:spcAft>
-            </a:pPr>
-            <a:r>
-              <a:rPr sz="2000" b="0">
-                <a:solidFill>
-                  <a:srgbClr val="5B6F68"/>
-                </a:solidFill>
-                <a:latin typeface="Calibri"/>
-              </a:rPr>
-              <a:t>the 1960 rocket</a:t>
-            </a:r>
-          </a:p>
-          <a:p>
-            <a:pPr algn="l">
-              <a:lnSpc>
-                <a:spcPct val="100000"/>
-              </a:lnSpc>
-              <a:spcAft>
-                <a:spcPts val="1000"/>
-              </a:spcAft>
-            </a:pPr>
-            <a:r>
-              <a:rPr sz="2000" b="0">
-                <a:solidFill>
-                  <a:srgbClr val="16241F"/>
-                </a:solidFill>
-                <a:latin typeface="Calibri"/>
-              </a:rPr>
-              <a:t>The sensor noise is the same everywhere.</a:t>
-            </a:r>
-          </a:p>
-          <a:p>
-            <a:pPr algn="l">
-              <a:lnSpc>
-                <a:spcPct val="100000"/>
-              </a:lnSpc>
-              <a:spcAft>
-                <a:spcPts val="1000"/>
-              </a:spcAft>
-            </a:pPr>
-            <a:r>
-              <a:rPr sz="2000" b="0">
-                <a:solidFill>
-                  <a:srgbClr val="16241F"/>
-                </a:solidFill>
-                <a:latin typeface="Calibri"/>
-              </a:rPr>
-              <a:t>So every move leaves the rocket equally uncertain.</a:t>
-            </a:r>
-          </a:p>
-          <a:p>
-            <a:pPr algn="l">
-              <a:lnSpc>
-                <a:spcPct val="100000"/>
-              </a:lnSpc>
-            </a:pPr>
-            <a:r>
-              <a:rPr sz="2000" b="0">
-                <a:solidFill>
-                  <a:srgbClr val="16241F"/>
-                </a:solidFill>
-                <a:latin typeface="Calibri"/>
-              </a:rPr>
-              <a:t>Expected free energy reduces to LQR.</a:t>
-            </a:r>
-          </a:p>
-        </p:txBody>
-      </p:sp>
-      <p:sp>
-        <p:nvSpPr>
-          <p:cNvPr id="5" name="card"/>
-          <p:cNvSpPr/>
-          <p:nvPr/>
-        </p:nvSpPr>
-        <p:spPr>
-          <a:xfrm>
-            <a:off x="6278727" y="1325880"/>
-            <a:ext cx="5364327" cy="3291840"/>
-          </a:xfrm>
-          <a:prstGeom prst="roundRect">
-            <a:avLst>
-              <a:gd name="adj" fmla="val 3333"/>
-            </a:avLst>
-          </a:prstGeom>
-          <a:solidFill>
-            <a:srgbClr val="FFFFFF"/>
-          </a:solidFill>
-          <a:ln>
-            <a:noFill/>
-          </a:ln>
-          <a:effectLst/>
-        </p:spPr>
-        <p:style>
-          <a:lnRef idx="1">
-            <a:schemeClr val="accent1"/>
-          </a:lnRef>
-          <a:fillRef idx="3">
-            <a:schemeClr val="accent1"/>
-          </a:fillRef>
-          <a:effectRef idx="2">
-            <a:schemeClr val="accent1"/>
-          </a:effectRef>
-          <a:fontRef idx="minor">
-            <a:schemeClr val="lt1"/>
-          </a:fontRef>
-        </p:style>
-        <p:txBody>
-          <a:bodyPr rtlCol="0" anchor="t" wrap="square" lIns="164592" rIns="164592" tIns="115214" bIns="115214"/>
-          <a:lstStyle/>
-          <a:p>
-            <a:pPr algn="l">
-              <a:lnSpc>
-                <a:spcPct val="100000"/>
-              </a:lnSpc>
-              <a:spcAft>
-                <a:spcPts val="1000"/>
-              </a:spcAft>
-            </a:pPr>
-            <a:r>
-              <a:rPr sz="4400" b="1">
-                <a:solidFill>
-                  <a:srgbClr val="8A6000"/>
-                </a:solidFill>
-                <a:latin typeface="Courier New"/>
-              </a:rPr>
-              <a:t>R(x)</a:t>
-            </a:r>
-          </a:p>
-          <a:p>
-            <a:pPr algn="l">
-              <a:lnSpc>
-                <a:spcPct val="100000"/>
-              </a:lnSpc>
-              <a:spcAft>
-                <a:spcPts val="1000"/>
-              </a:spcAft>
-            </a:pPr>
-            <a:r>
-              <a:rPr sz="2000" b="0">
-                <a:solidFill>
-                  <a:srgbClr val="5B6F68"/>
-                </a:solidFill>
-                <a:latin typeface="Calibri"/>
-              </a:rPr>
-              <a:t>a curious rocket</a:t>
-            </a:r>
-          </a:p>
-          <a:p>
-            <a:pPr algn="l">
-              <a:lnSpc>
-                <a:spcPct val="100000"/>
-              </a:lnSpc>
-              <a:spcAft>
-                <a:spcPts val="1000"/>
-              </a:spcAft>
-            </a:pPr>
-            <a:r>
-              <a:rPr sz="2000" b="0">
-                <a:solidFill>
-                  <a:srgbClr val="16241F"/>
-                </a:solidFill>
-                <a:latin typeface="Calibri"/>
-              </a:rPr>
-              <a:t>The sensor noise depends on where the rocket is.</a:t>
-            </a:r>
-          </a:p>
-          <a:p>
-            <a:pPr algn="l">
-              <a:lnSpc>
-                <a:spcPct val="100000"/>
-              </a:lnSpc>
-              <a:spcAft>
-                <a:spcPts val="1000"/>
-              </a:spcAft>
-            </a:pPr>
-            <a:r>
-              <a:rPr sz="2000" b="0">
-                <a:solidFill>
-                  <a:srgbClr val="16241F"/>
-                </a:solidFill>
-                <a:latin typeface="Calibri"/>
-              </a:rPr>
-              <a:t>So where a move lands changes how informative the next reading is.</a:t>
-            </a:r>
-          </a:p>
-          <a:p>
-            <a:pPr algn="l">
-              <a:lnSpc>
-                <a:spcPct val="100000"/>
-              </a:lnSpc>
-            </a:pPr>
-            <a:r>
-              <a:rPr sz="2000" b="0">
-                <a:solidFill>
-                  <a:srgbClr val="16241F"/>
-                </a:solidFill>
-                <a:latin typeface="Calibri"/>
-              </a:rPr>
-              <a:t>Tasks 2 and 3 build it.</a:t>
-            </a:r>
-          </a:p>
-        </p:txBody>
-      </p:sp>
-      <p:sp>
-        <p:nvSpPr>
-          <p:cNvPr id="6" name="text"/>
-          <p:cNvSpPr txBox="1"/>
-          <p:nvPr/>
-        </p:nvSpPr>
-        <p:spPr>
-          <a:xfrm>
-            <a:off x="548640" y="4892040"/>
-            <a:ext cx="11094415" cy="1280160"/>
+            <a:ext cx="11094415" cy="640080"/>
           </a:xfrm>
           <a:prstGeom prst="rect">
             <a:avLst/>
@@ -8346,34 +8043,249 @@
               <a:lnSpc>
                 <a:spcPct val="100000"/>
               </a:lnSpc>
-              <a:spcAft>
-                <a:spcPts val="1000"/>
-              </a:spcAft>
-            </a:pPr>
-            <a:r>
-              <a:rPr sz="2000" b="0">
+            </a:pPr>
+            <a:r>
+              <a:rPr sz="2200" b="0">
                 <a:solidFill>
                   <a:srgbClr val="16241F"/>
                 </a:solidFill>
                 <a:latin typeface="Calibri"/>
               </a:rPr>
-              <a:t>With fixed noise in a linear Gaussian model, the expected information gain is the same for every action, so curiosity can't change what the rocket does.</a:t>
-            </a:r>
-          </a:p>
-          <a:p>
-            <a:pPr algn="l">
-              <a:lnSpc>
-                <a:spcPct val="100000"/>
-              </a:lnSpc>
-            </a:pPr>
-            <a:r>
-              <a:rPr sz="1600" b="0">
+              <a:t>In cpomdp, sensor noise can depend on the rocket’s position: R(x).</a:t>
+            </a:r>
+          </a:p>
+        </p:txBody>
+      </p:sp>
+      <p:sp>
+        <p:nvSpPr>
+          <p:cNvPr id="5" name="text"/>
+          <p:cNvSpPr txBox="1"/>
+          <p:nvPr/>
+        </p:nvSpPr>
+        <p:spPr>
+          <a:xfrm>
+            <a:off x="548640" y="2286000"/>
+            <a:ext cx="11094415" cy="457200"/>
+          </a:xfrm>
+          <a:prstGeom prst="rect">
+            <a:avLst/>
+          </a:prstGeom>
+          <a:noFill/>
+        </p:spPr>
+        <p:txBody>
+          <a:bodyPr wrap="square" lIns="0" rIns="0" tIns="0" bIns="0" anchor="t">
+            <a:spAutoFit/>
+          </a:bodyPr>
+          <a:lstStyle/>
+          <a:p>
+            <a:pPr algn="ctr">
+              <a:lnSpc>
+                <a:spcPct val="100000"/>
+              </a:lnSpc>
+            </a:pPr>
+            <a:r>
+              <a:rPr sz="2400" b="1">
+                <a:solidFill>
+                  <a:srgbClr val="16241F"/>
+                </a:solidFill>
+                <a:latin typeface="Calibri"/>
+              </a:rPr>
+              <a:t>Where the rocket moves</a:t>
+            </a:r>
+          </a:p>
+        </p:txBody>
+      </p:sp>
+      <p:sp>
+        <p:nvSpPr>
+          <p:cNvPr id="6" name="text"/>
+          <p:cNvSpPr txBox="1"/>
+          <p:nvPr/>
+        </p:nvSpPr>
+        <p:spPr>
+          <a:xfrm>
+            <a:off x="548640" y="2834640"/>
+            <a:ext cx="11094415" cy="365760"/>
+          </a:xfrm>
+          <a:prstGeom prst="rect">
+            <a:avLst/>
+          </a:prstGeom>
+          <a:noFill/>
+        </p:spPr>
+        <p:txBody>
+          <a:bodyPr wrap="square" lIns="0" rIns="0" tIns="0" bIns="0" anchor="t">
+            <a:spAutoFit/>
+          </a:bodyPr>
+          <a:lstStyle/>
+          <a:p>
+            <a:pPr algn="ctr">
+              <a:lnSpc>
+                <a:spcPct val="100000"/>
+              </a:lnSpc>
+            </a:pPr>
+            <a:r>
+              <a:rPr sz="2400" b="0">
                 <a:solidFill>
                   <a:srgbClr val="5B6F68"/>
                 </a:solidFill>
                 <a:latin typeface="Calibri"/>
               </a:rPr>
-              <a:t>Koudahl, Kouw &amp; de Vries, 2021</a:t>
+              <a:t>↓</a:t>
+            </a:r>
+          </a:p>
+        </p:txBody>
+      </p:sp>
+      <p:sp>
+        <p:nvSpPr>
+          <p:cNvPr id="7" name="text"/>
+          <p:cNvSpPr txBox="1"/>
+          <p:nvPr/>
+        </p:nvSpPr>
+        <p:spPr>
+          <a:xfrm>
+            <a:off x="548640" y="3383280"/>
+            <a:ext cx="11094415" cy="457200"/>
+          </a:xfrm>
+          <a:prstGeom prst="rect">
+            <a:avLst/>
+          </a:prstGeom>
+          <a:noFill/>
+        </p:spPr>
+        <p:txBody>
+          <a:bodyPr wrap="square" lIns="0" rIns="0" tIns="0" bIns="0" anchor="t">
+            <a:spAutoFit/>
+          </a:bodyPr>
+          <a:lstStyle/>
+          <a:p>
+            <a:pPr algn="ctr">
+              <a:lnSpc>
+                <a:spcPct val="100000"/>
+              </a:lnSpc>
+            </a:pPr>
+            <a:r>
+              <a:rPr sz="2400" b="1">
+                <a:solidFill>
+                  <a:srgbClr val="16241F"/>
+                </a:solidFill>
+                <a:latin typeface="Calibri"/>
+              </a:rPr>
+              <a:t>How reliable its next reading is</a:t>
+            </a:r>
+          </a:p>
+        </p:txBody>
+      </p:sp>
+      <p:sp>
+        <p:nvSpPr>
+          <p:cNvPr id="8" name="text"/>
+          <p:cNvSpPr txBox="1"/>
+          <p:nvPr/>
+        </p:nvSpPr>
+        <p:spPr>
+          <a:xfrm>
+            <a:off x="548640" y="3931920"/>
+            <a:ext cx="11094415" cy="365760"/>
+          </a:xfrm>
+          <a:prstGeom prst="rect">
+            <a:avLst/>
+          </a:prstGeom>
+          <a:noFill/>
+        </p:spPr>
+        <p:txBody>
+          <a:bodyPr wrap="square" lIns="0" rIns="0" tIns="0" bIns="0" anchor="t">
+            <a:spAutoFit/>
+          </a:bodyPr>
+          <a:lstStyle/>
+          <a:p>
+            <a:pPr algn="ctr">
+              <a:lnSpc>
+                <a:spcPct val="100000"/>
+              </a:lnSpc>
+            </a:pPr>
+            <a:r>
+              <a:rPr sz="2400" b="0">
+                <a:solidFill>
+                  <a:srgbClr val="5B6F68"/>
+                </a:solidFill>
+                <a:latin typeface="Calibri"/>
+              </a:rPr>
+              <a:t>↓</a:t>
+            </a:r>
+          </a:p>
+        </p:txBody>
+      </p:sp>
+      <p:sp>
+        <p:nvSpPr>
+          <p:cNvPr id="9" name="text"/>
+          <p:cNvSpPr txBox="1"/>
+          <p:nvPr/>
+        </p:nvSpPr>
+        <p:spPr>
+          <a:xfrm>
+            <a:off x="548640" y="4480560"/>
+            <a:ext cx="11094415" cy="457200"/>
+          </a:xfrm>
+          <a:prstGeom prst="rect">
+            <a:avLst/>
+          </a:prstGeom>
+          <a:noFill/>
+        </p:spPr>
+        <p:txBody>
+          <a:bodyPr wrap="square" lIns="0" rIns="0" tIns="0" bIns="0" anchor="t">
+            <a:spAutoFit/>
+          </a:bodyPr>
+          <a:lstStyle/>
+          <a:p>
+            <a:pPr algn="ctr">
+              <a:lnSpc>
+                <a:spcPct val="100000"/>
+              </a:lnSpc>
+            </a:pPr>
+            <a:r>
+              <a:rPr sz="2400" b="1">
+                <a:solidFill>
+                  <a:srgbClr val="16241F"/>
+                </a:solidFill>
+                <a:latin typeface="Calibri"/>
+              </a:rPr>
+              <a:t>How much it expects to learn</a:t>
+            </a:r>
+          </a:p>
+        </p:txBody>
+      </p:sp>
+      <p:sp>
+        <p:nvSpPr>
+          <p:cNvPr id="10" name="text"/>
+          <p:cNvSpPr txBox="1"/>
+          <p:nvPr/>
+        </p:nvSpPr>
+        <p:spPr>
+          <a:xfrm>
+            <a:off x="548640" y="5806440"/>
+            <a:ext cx="11094415" cy="502920"/>
+          </a:xfrm>
+          <a:prstGeom prst="rect">
+            <a:avLst/>
+          </a:prstGeom>
+          <a:noFill/>
+        </p:spPr>
+        <p:txBody>
+          <a:bodyPr wrap="square" lIns="0" rIns="0" tIns="0" bIns="0" anchor="t">
+            <a:spAutoFit/>
+          </a:bodyPr>
+          <a:lstStyle/>
+          <a:p>
+            <a:pPr algn="l">
+              <a:lnSpc>
+                <a:spcPct val="100000"/>
+              </a:lnSpc>
+            </a:pPr>
+            <a:r>
+              <a:rPr sz="2200" b="1">
+                <a:solidFill>
+                  <a:srgbClr val="8A6000"/>
+                </a:solidFill>
+                <a:latin typeface="Calibri"/>
+              </a:rPr>
+              <a:t>Some moves can now offer more information than others.</a:t>
             </a:r>
           </a:p>
         </p:txBody>
@@ -25148,7 +25060,7 @@
                 </a:solidFill>
                 <a:latin typeface="Calibri"/>
               </a:rPr>
-              <a:t>How we'll work</a:t>
+              <a:t>How we will work</a:t>
             </a:r>
           </a:p>
         </p:txBody>
@@ -25269,7 +25181,7 @@
                 </a:solidFill>
                 <a:latin typeface="Calibri"/>
               </a:rPr>
-              <a:t>Two lines per task</a:t>
+              <a:t>Two lines to complete</a:t>
             </a:r>
           </a:p>
           <a:p>
@@ -25285,7 +25197,7 @@
                 </a:solidFill>
                 <a:latin typeface="Calibri"/>
               </a:rPr>
-              <a:t>Each task has two lines marked </a:t>
+              <a:t>In each task, you will fill in two lines marked </a:t>
             </a:r>
             <a:r>
               <a:rPr sz="1800" b="1">
@@ -25303,7 +25215,7 @@
                 </a:solidFill>
                 <a:latin typeface="Calibri"/>
               </a:rPr>
-              <a:t> for you to write. We've written the rest, so you can focus on the key concepts without worrying about the Python. Some bonus exercises ask you to write your own.</a:t>
+              <a:t>. We have written the rest so you can focus on the ideas. Some bonus exercises give you a chance to write more of your own code.</a:t>
             </a:r>
           </a:p>
         </p:txBody>
@@ -25365,7 +25277,7 @@
                 </a:solidFill>
                 <a:latin typeface="Calibri"/>
               </a:rPr>
-              <a:t>Hints when you need them</a:t>
+              <a:t>Help whenever you need it</a:t>
             </a:r>
           </a:p>
           <a:p>
@@ -25381,7 +25293,7 @@
                 </a:solidFill>
                 <a:latin typeface="Calibri"/>
               </a:rPr>
-              <a:t>Each task has two hints and a reference solution, collapsed below the code cell. Open them whenever you like, and using them is absolutely fine.</a:t>
+              <a:t>You will find two hints and a worked solution below each task’s code cell. Click to open them whenever you like. They are there to help, so use them freely.</a:t>
             </a:r>
           </a:p>
         </p:txBody>
@@ -25459,7 +25371,7 @@
                 </a:solidFill>
                 <a:latin typeface="Calibri"/>
               </a:rPr>
-              <a:t>Run the checkpoint cell at the end of every task, even if everything worked. It restores the setup the next task needs.</a:t>
+              <a:t>At the end of each task, run the checkpoint cell, even if your code worked. This gives everyone the same starting point for the next task.</a:t>
             </a:r>
           </a:p>
         </p:txBody>
@@ -25521,7 +25433,7 @@
                 </a:solidFill>
                 <a:latin typeface="Calibri"/>
               </a:rPr>
-              <a:t>One number in the chat</a:t>
+              <a:t>Share your result</a:t>
             </a:r>
           </a:p>
           <a:p>
@@ -25537,7 +25449,7 @@
                 </a:solidFill>
                 <a:latin typeface="Calibri"/>
               </a:rPr>
-              <a:t>Each task ends with one number to paste in the chat, then a 60-second poll.</a:t>
+              <a:t>Paste the number requested at the end of the task into the chat. We will then take a one-minute poll.</a:t>
             </a:r>
           </a:p>
         </p:txBody>
@@ -25576,7 +25488,7 @@
                 </a:solidFill>
                 <a:latin typeface="Calibri"/>
               </a:rPr>
-              <a:t>The aim is to explore the ideas behind the code, rather than test your programming skills. Questions are welcome any time, in the chat or on the anonymous form.</a:t>
+              <a:t>The focus is on understanding the ideas behind the code. Questions are welcome throughout, in the chat or through the anonymous form.</a:t>
             </a:r>
           </a:p>
         </p:txBody>
@@ -26186,7 +26098,7 @@
                 </a:solidFill>
                 <a:latin typeface="Calibri"/>
               </a:rPr>
-              <a:t>Where we're heading</a:t>
+              <a:t>What we will build</a:t>
             </a:r>
           </a:p>
         </p:txBody>
@@ -26283,7 +26195,7 @@
         <p:spPr>
           <a:xfrm>
             <a:off x="8503920" y="1325880"/>
-            <a:ext cx="3139135" cy="3291840"/>
+            <a:ext cx="3139135" cy="4297680"/>
           </a:xfrm>
           <a:prstGeom prst="rect">
             <a:avLst/>
@@ -26311,7 +26223,7 @@
                 </a:solidFill>
                 <a:latin typeface="Calibri"/>
               </a:rPr>
-              <a:t>By the end of Task 3, we'll have built this picture.</a:t>
+              <a:t>By the end of Task 3, we will have built the models that produce these three rocket paths.</a:t>
             </a:r>
           </a:p>
           <a:p>
@@ -26330,7 +26242,7 @@
                 </a:solidFill>
                 <a:latin typeface="Calibri"/>
               </a:rPr>
-              <a:t>Three rockets, one rock. The dashed line is the 1960 rocket.</a:t>
+              <a:t>The dashed line shows the 1960 rocket. The coloured lines show two versions of the curious rocket.</a:t>
             </a:r>
           </a:p>
           <a:p>
@@ -26346,7 +26258,7 @@
                 </a:solidFill>
                 <a:latin typeface="Calibri"/>
               </a:rPr>
-              <a:t>Cell 2 draws it. </a:t>
+              <a:t>Run the second code cell to see the preview: </a:t>
             </a:r>
             <a:r>
               <a:rPr sz="1900" b="0">
@@ -26560,15 +26472,17 @@
                 </a:solidFill>
                 <a:latin typeface="Calibri"/>
               </a:rPr>
-              <a:t>A Kalman filter estimates where the rocket is from noisy sensor readings, and a linear quadratic regulator (LQR) steers it to the landing pad.</a:t>
-            </a:r>
-          </a:p>
-          <a:p>
-            <a:pPr algn="l">
-              <a:lnSpc>
-                <a:spcPct val="100000"/>
-              </a:lnSpc>
-            </a:pPr>
+              <a:t>A </a:t>
+            </a:r>
+            <a:r>
+              <a:rPr sz="2100" b="1">
+                <a:solidFill>
+                  <a:srgbClr val="16241F"/>
+                </a:solidFill>
+                <a:latin typeface="Calibri"/>
+              </a:rPr>
+              <a:t>Kalman filter</a:t>
+            </a:r>
             <a:r>
               <a:rPr sz="2100" b="0">
                 <a:solidFill>
@@ -26576,7 +26490,60 @@
                 </a:solidFill>
                 <a:latin typeface="Calibri"/>
               </a:rPr>
-              <a:t>The sensor is equally reliable wherever the rocket flies.</a:t>
+              <a:t> estimates the rocket’s position from noisy sensor readings.</a:t>
+            </a:r>
+          </a:p>
+          <a:p>
+            <a:pPr algn="l">
+              <a:lnSpc>
+                <a:spcPct val="100000"/>
+              </a:lnSpc>
+              <a:spcAft>
+                <a:spcPts val="1200"/>
+              </a:spcAft>
+            </a:pPr>
+            <a:r>
+              <a:rPr sz="2100" b="0">
+                <a:solidFill>
+                  <a:srgbClr val="16241F"/>
+                </a:solidFill>
+                <a:latin typeface="Calibri"/>
+              </a:rPr>
+              <a:t>A </a:t>
+            </a:r>
+            <a:r>
+              <a:rPr sz="2100" b="1">
+                <a:solidFill>
+                  <a:srgbClr val="16241F"/>
+                </a:solidFill>
+                <a:latin typeface="Calibri"/>
+              </a:rPr>
+              <a:t>linear quadratic regulator (LQR)</a:t>
+            </a:r>
+            <a:r>
+              <a:rPr sz="2100" b="0">
+                <a:solidFill>
+                  <a:srgbClr val="16241F"/>
+                </a:solidFill>
+                <a:latin typeface="Calibri"/>
+              </a:rPr>
+              <a:t> steers the rocket towards the landing pad.</a:t>
+            </a:r>
+          </a:p>
+          <a:p>
+            <a:pPr algn="l">
+              <a:lnSpc>
+                <a:spcPct val="100000"/>
+              </a:lnSpc>
+            </a:pPr>
+            <a:r>
+              <a:rPr sz="2100" b="0">
+                <a:solidFill>
+                  <a:srgbClr val="16241F"/>
+                </a:solidFill>
+                <a:latin typeface="Calibri"/>
+              </a:rPr>
+              <a:t>The sensor has the same level of noise wherever the rocket flies.</a:t>
             </a:r>
           </a:p>
         </p:txBody>
@@ -26590,7 +26557,7 @@
         <p:spPr>
           <a:xfrm>
             <a:off x="548640" y="2926080"/>
-            <a:ext cx="11094415" cy="868680"/>
+            <a:ext cx="11094415" cy="502920"/>
           </a:xfrm>
           <a:prstGeom prst="rect">
             <a:avLst/>
@@ -26615,7 +26582,46 @@
                 </a:solidFill>
                 <a:latin typeface="Calibri"/>
               </a:rPr>
-              <a:t>Does that make every move equally informative?</a:t>
+              <a:t>Are all possible moves equally informative?</a:t>
+            </a:r>
+          </a:p>
+        </p:txBody>
+      </p:sp>
+      <p:sp>
+        <p:nvSpPr>
+          <p:cNvPr id="10" name="text"/>
+          <p:cNvSpPr txBox="1"/>
+          <p:nvPr/>
+        </p:nvSpPr>
+        <p:spPr>
+          <a:xfrm>
+            <a:off x="548640" y="3566160"/>
+            <a:ext cx="11094415" cy="274320"/>
+          </a:xfrm>
+          <a:prstGeom prst="rect">
+            <a:avLst/>
+          </a:prstGeom>
+          <a:noFill/>
+        </p:spPr>
+        <p:txBody>
+          <a:bodyPr wrap="square" lIns="0" rIns="0" tIns="0" bIns="0" anchor="t">
+            <a:spAutoFit/>
+          </a:bodyPr>
+          <a:lstStyle/>
+          <a:p>
+            <a:pPr algn="l">
+              <a:lnSpc>
+                <a:spcPct val="100000"/>
+              </a:lnSpc>
+            </a:pPr>
+            <a:r>
+              <a:rPr sz="1500" b="0">
+                <a:solidFill>
+                  <a:srgbClr val="5B6F68"/>
+                </a:solidFill>
+                <a:latin typeface="Calibri"/>
+              </a:rPr>
+              <a:t>pymdp notation and the corresponding cpomdp fields</a:t>
             </a:r>
           </a:p>
         </p:txBody>

</xml_diff>